<commit_message>
seminar: mark figure-attachment spots on PPT slides
Add yellow "📎 사진 첨부" chips to 22 slides indicating where each
figure should be inserted (structure renders, PDOS, Arrhenius, ELF,
elastic bars, BVSE, etc.). Chip lives in the empty right portion of
the title bar so existing layouts are untouched.

https://claude.ai/code/session_018pDuSCy524WqJCVpWjX7nn
</commit_message>
<xml_diff>
--- a/kb/papers/lpscl_vs_lpscl16_seminar_v1.pptx
+++ b/kb/papers/lpscl_vs_lpscl16_seminar_v1.pptx
@@ -4585,6 +4585,61 @@
           </a:p>
         </p:txBody>
       </p:sp>
+      <p:sp>
+        <p:nvSpPr>
+          <p:cNvPr id="12" name="Rounded Rectangle 11"/>
+          <p:cNvSpPr/>
+          <p:nvPr/>
+        </p:nvSpPr>
+        <p:spPr>
+          <a:xfrm>
+            <a:off x="7528255" y="347472"/>
+            <a:ext cx="4206240" cy="384048"/>
+          </a:xfrm>
+          <a:prstGeom prst="roundRect">
+            <a:avLst/>
+          </a:prstGeom>
+          <a:solidFill>
+            <a:srgbClr val="FFF19A"/>
+          </a:solidFill>
+          <a:ln w="12700">
+            <a:solidFill>
+              <a:srgbClr val="C89A00"/>
+            </a:solidFill>
+          </a:ln>
+          <a:effectLst/>
+        </p:spPr>
+        <p:style>
+          <a:lnRef idx="1">
+            <a:schemeClr val="accent1"/>
+          </a:lnRef>
+          <a:fillRef idx="3">
+            <a:schemeClr val="accent1"/>
+          </a:fillRef>
+          <a:effectRef idx="2">
+            <a:schemeClr val="accent1"/>
+          </a:effectRef>
+          <a:fontRef idx="minor">
+            <a:schemeClr val="lt1"/>
+          </a:fontRef>
+        </p:style>
+        <p:txBody>
+          <a:bodyPr rtlCol="0" anchor="ctr" wrap="square" lIns="73152" rIns="73152" tIns="18288" bIns="18288"/>
+          <a:lstStyle/>
+          <a:p>
+            <a:pPr algn="l"/>
+            <a:r>
+              <a:rPr sz="1000" b="1">
+                <a:solidFill>
+                  <a:srgbClr val="664D00"/>
+                </a:solidFill>
+                <a:latin typeface="맑은 고딕"/>
+              </a:rPr>
+              <a:t>📎 사진 첨부: Cohesive / Li–anion ionic glue 모식도 또는 막대</a:t>
+            </a:r>
+          </a:p>
+        </p:txBody>
+      </p:sp>
     </p:spTree>
   </p:cSld>
   <p:clrMapOvr>
@@ -5918,6 +5973,61 @@
           </a:p>
         </p:txBody>
       </p:sp>
+      <p:sp>
+        <p:nvSpPr>
+          <p:cNvPr id="12" name="Rounded Rectangle 11"/>
+          <p:cNvSpPr/>
+          <p:nvPr/>
+        </p:nvSpPr>
+        <p:spPr>
+          <a:xfrm>
+            <a:off x="7528255" y="347472"/>
+            <a:ext cx="4206240" cy="384048"/>
+          </a:xfrm>
+          <a:prstGeom prst="roundRect">
+            <a:avLst/>
+          </a:prstGeom>
+          <a:solidFill>
+            <a:srgbClr val="FFF19A"/>
+          </a:solidFill>
+          <a:ln w="12700">
+            <a:solidFill>
+              <a:srgbClr val="C89A00"/>
+            </a:solidFill>
+          </a:ln>
+          <a:effectLst/>
+        </p:spPr>
+        <p:style>
+          <a:lnRef idx="1">
+            <a:schemeClr val="accent1"/>
+          </a:lnRef>
+          <a:fillRef idx="3">
+            <a:schemeClr val="accent1"/>
+          </a:fillRef>
+          <a:effectRef idx="2">
+            <a:schemeClr val="accent1"/>
+          </a:effectRef>
+          <a:fontRef idx="minor">
+            <a:schemeClr val="lt1"/>
+          </a:fontRef>
+        </p:style>
+        <p:txBody>
+          <a:bodyPr rtlCol="0" anchor="ctr" wrap="square" lIns="73152" rIns="73152" tIns="18288" bIns="18288"/>
+          <a:lstStyle/>
+          <a:p>
+            <a:pPr algn="l"/>
+            <a:r>
+              <a:rPr sz="1000" b="1">
+                <a:solidFill>
+                  <a:srgbClr val="664D00"/>
+                </a:solidFill>
+                <a:latin typeface="맑은 고딕"/>
+              </a:rPr>
+              <a:t>📎 사진 첨부: Elastic moduli (B, G, E) clamped vs relaxed 비교 막대</a:t>
+            </a:r>
+          </a:p>
+        </p:txBody>
+      </p:sp>
     </p:spTree>
   </p:cSld>
   <p:clrMapOvr>
@@ -6910,6 +7020,61 @@
           </a:p>
         </p:txBody>
       </p:sp>
+      <p:sp>
+        <p:nvSpPr>
+          <p:cNvPr id="11" name="Rounded Rectangle 10"/>
+          <p:cNvSpPr/>
+          <p:nvPr/>
+        </p:nvSpPr>
+        <p:spPr>
+          <a:xfrm>
+            <a:off x="7528255" y="347472"/>
+            <a:ext cx="4206240" cy="384048"/>
+          </a:xfrm>
+          <a:prstGeom prst="roundRect">
+            <a:avLst/>
+          </a:prstGeom>
+          <a:solidFill>
+            <a:srgbClr val="FFF19A"/>
+          </a:solidFill>
+          <a:ln w="12700">
+            <a:solidFill>
+              <a:srgbClr val="C89A00"/>
+            </a:solidFill>
+          </a:ln>
+          <a:effectLst/>
+        </p:spPr>
+        <p:style>
+          <a:lnRef idx="1">
+            <a:schemeClr val="accent1"/>
+          </a:lnRef>
+          <a:fillRef idx="3">
+            <a:schemeClr val="accent1"/>
+          </a:fillRef>
+          <a:effectRef idx="2">
+            <a:schemeClr val="accent1"/>
+          </a:effectRef>
+          <a:fontRef idx="minor">
+            <a:schemeClr val="lt1"/>
+          </a:fontRef>
+        </p:style>
+        <p:txBody>
+          <a:bodyPr rtlCol="0" anchor="ctr" wrap="square" lIns="73152" rIns="73152" tIns="18288" bIns="18288"/>
+          <a:lstStyle/>
+          <a:p>
+            <a:pPr algn="l"/>
+            <a:r>
+              <a:rPr sz="1000" b="1">
+                <a:solidFill>
+                  <a:srgbClr val="664D00"/>
+                </a:solidFill>
+                <a:latin typeface="맑은 고딕"/>
+              </a:rPr>
+              <a:t>📎 사진 첨부: Cij component bar (C44 강조)</a:t>
+            </a:r>
+          </a:p>
+        </p:txBody>
+      </p:sp>
     </p:spTree>
   </p:cSld>
   <p:clrMapOvr>
@@ -7710,6 +7875,61 @@
           </a:p>
         </p:txBody>
       </p:sp>
+      <p:sp>
+        <p:nvSpPr>
+          <p:cNvPr id="8" name="Rounded Rectangle 7"/>
+          <p:cNvSpPr/>
+          <p:nvPr/>
+        </p:nvSpPr>
+        <p:spPr>
+          <a:xfrm>
+            <a:off x="7528255" y="347472"/>
+            <a:ext cx="4206240" cy="384048"/>
+          </a:xfrm>
+          <a:prstGeom prst="roundRect">
+            <a:avLst/>
+          </a:prstGeom>
+          <a:solidFill>
+            <a:srgbClr val="FFF19A"/>
+          </a:solidFill>
+          <a:ln w="12700">
+            <a:solidFill>
+              <a:srgbClr val="C89A00"/>
+            </a:solidFill>
+          </a:ln>
+          <a:effectLst/>
+        </p:spPr>
+        <p:style>
+          <a:lnRef idx="1">
+            <a:schemeClr val="accent1"/>
+          </a:lnRef>
+          <a:fillRef idx="3">
+            <a:schemeClr val="accent1"/>
+          </a:fillRef>
+          <a:effectRef idx="2">
+            <a:schemeClr val="accent1"/>
+          </a:effectRef>
+          <a:fontRef idx="minor">
+            <a:schemeClr val="lt1"/>
+          </a:fontRef>
+        </p:style>
+        <p:txBody>
+          <a:bodyPr rtlCol="0" anchor="ctr" wrap="square" lIns="73152" rIns="73152" tIns="18288" bIns="18288"/>
+          <a:lstStyle/>
+          <a:p>
+            <a:pPr algn="l"/>
+            <a:r>
+              <a:rPr sz="1000" b="1">
+                <a:solidFill>
+                  <a:srgbClr val="664D00"/>
+                </a:solidFill>
+                <a:latin typeface="맑은 고딕"/>
+              </a:rPr>
+              <a:t>📎 사진 첨부: M4 4 cross-check 수렴 그림</a:t>
+            </a:r>
+          </a:p>
+        </p:txBody>
+      </p:sp>
     </p:spTree>
   </p:cSld>
   <p:clrMapOvr>
@@ -8719,6 +8939,61 @@
           </a:p>
         </p:txBody>
       </p:sp>
+      <p:sp>
+        <p:nvSpPr>
+          <p:cNvPr id="9" name="Rounded Rectangle 8"/>
+          <p:cNvSpPr/>
+          <p:nvPr/>
+        </p:nvSpPr>
+        <p:spPr>
+          <a:xfrm>
+            <a:off x="7528255" y="347472"/>
+            <a:ext cx="4206240" cy="384048"/>
+          </a:xfrm>
+          <a:prstGeom prst="roundRect">
+            <a:avLst/>
+          </a:prstGeom>
+          <a:solidFill>
+            <a:srgbClr val="FFF19A"/>
+          </a:solidFill>
+          <a:ln w="12700">
+            <a:solidFill>
+              <a:srgbClr val="C89A00"/>
+            </a:solidFill>
+          </a:ln>
+          <a:effectLst/>
+        </p:spPr>
+        <p:style>
+          <a:lnRef idx="1">
+            <a:schemeClr val="accent1"/>
+          </a:lnRef>
+          <a:fillRef idx="3">
+            <a:schemeClr val="accent1"/>
+          </a:fillRef>
+          <a:effectRef idx="2">
+            <a:schemeClr val="accent1"/>
+          </a:effectRef>
+          <a:fontRef idx="minor">
+            <a:schemeClr val="lt1"/>
+          </a:fontRef>
+        </p:style>
+        <p:txBody>
+          <a:bodyPr rtlCol="0" anchor="ctr" wrap="square" lIns="73152" rIns="73152" tIns="18288" bIns="18288"/>
+          <a:lstStyle/>
+          <a:p>
+            <a:pPr algn="l"/>
+            <a:r>
+              <a:rPr sz="1000" b="1">
+                <a:solidFill>
+                  <a:srgbClr val="664D00"/>
+                </a:solidFill>
+                <a:latin typeface="맑은 고딕"/>
+              </a:rPr>
+              <a:t>📎 사진 첨부: PS₄ 결합 길이/각도 히스토그램 (두 시스템 overlay)</a:t>
+            </a:r>
+          </a:p>
+        </p:txBody>
+      </p:sp>
     </p:spTree>
   </p:cSld>
   <p:clrMapOvr>
@@ -9884,6 +10159,61 @@
           </a:p>
         </p:txBody>
       </p:sp>
+      <p:sp>
+        <p:nvSpPr>
+          <p:cNvPr id="12" name="Rounded Rectangle 11"/>
+          <p:cNvSpPr/>
+          <p:nvPr/>
+        </p:nvSpPr>
+        <p:spPr>
+          <a:xfrm>
+            <a:off x="7528255" y="347472"/>
+            <a:ext cx="4206240" cy="384048"/>
+          </a:xfrm>
+          <a:prstGeom prst="roundRect">
+            <a:avLst/>
+          </a:prstGeom>
+          <a:solidFill>
+            <a:srgbClr val="FFF19A"/>
+          </a:solidFill>
+          <a:ln w="12700">
+            <a:solidFill>
+              <a:srgbClr val="C89A00"/>
+            </a:solidFill>
+          </a:ln>
+          <a:effectLst/>
+        </p:spPr>
+        <p:style>
+          <a:lnRef idx="1">
+            <a:schemeClr val="accent1"/>
+          </a:lnRef>
+          <a:fillRef idx="3">
+            <a:schemeClr val="accent1"/>
+          </a:fillRef>
+          <a:effectRef idx="2">
+            <a:schemeClr val="accent1"/>
+          </a:effectRef>
+          <a:fontRef idx="minor">
+            <a:schemeClr val="lt1"/>
+          </a:fontRef>
+        </p:style>
+        <p:txBody>
+          <a:bodyPr rtlCol="0" anchor="ctr" wrap="square" lIns="73152" rIns="73152" tIns="18288" bIns="18288"/>
+          <a:lstStyle/>
+          <a:p>
+            <a:pPr algn="l"/>
+            <a:r>
+              <a:rPr sz="1000" b="1">
+                <a:solidFill>
+                  <a:srgbClr val="664D00"/>
+                </a:solidFill>
+                <a:latin typeface="맑은 고딕"/>
+              </a:rPr>
+              <a:t>📎 사진 첨부: Li–Cl per-bond 히스토그램 (4a vs 4d-AS 분리)</a:t>
+            </a:r>
+          </a:p>
+        </p:txBody>
+      </p:sp>
     </p:spTree>
   </p:cSld>
   <p:clrMapOvr>
@@ -10825,6 +11155,61 @@
           </a:p>
         </p:txBody>
       </p:sp>
+      <p:sp>
+        <p:nvSpPr>
+          <p:cNvPr id="11" name="Rounded Rectangle 10"/>
+          <p:cNvSpPr/>
+          <p:nvPr/>
+        </p:nvSpPr>
+        <p:spPr>
+          <a:xfrm>
+            <a:off x="7528255" y="347472"/>
+            <a:ext cx="4206240" cy="384048"/>
+          </a:xfrm>
+          <a:prstGeom prst="roundRect">
+            <a:avLst/>
+          </a:prstGeom>
+          <a:solidFill>
+            <a:srgbClr val="FFF19A"/>
+          </a:solidFill>
+          <a:ln w="12700">
+            <a:solidFill>
+              <a:srgbClr val="C89A00"/>
+            </a:solidFill>
+          </a:ln>
+          <a:effectLst/>
+        </p:spPr>
+        <p:style>
+          <a:lnRef idx="1">
+            <a:schemeClr val="accent1"/>
+          </a:lnRef>
+          <a:fillRef idx="3">
+            <a:schemeClr val="accent1"/>
+          </a:fillRef>
+          <a:effectRef idx="2">
+            <a:schemeClr val="accent1"/>
+          </a:effectRef>
+          <a:fontRef idx="minor">
+            <a:schemeClr val="lt1"/>
+          </a:fontRef>
+        </p:style>
+        <p:txBody>
+          <a:bodyPr rtlCol="0" anchor="ctr" wrap="square" lIns="73152" rIns="73152" tIns="18288" bIns="18288"/>
+          <a:lstStyle/>
+          <a:p>
+            <a:pPr algn="l"/>
+            <a:r>
+              <a:rPr sz="1000" b="1">
+                <a:solidFill>
+                  <a:srgbClr val="664D00"/>
+                </a:solidFill>
+                <a:latin typeface="맑은 고딕"/>
+              </a:rPr>
+              <a:t>📎 사진 첨부: Voronoi 4-sublattice 모식도 (4a/4b/4c/4d)</a:t>
+            </a:r>
+          </a:p>
+        </p:txBody>
+      </p:sp>
     </p:spTree>
   </p:cSld>
   <p:clrMapOvr>
@@ -11755,6 +12140,61 @@
           </a:p>
         </p:txBody>
       </p:sp>
+      <p:sp>
+        <p:nvSpPr>
+          <p:cNvPr id="11" name="Rounded Rectangle 10"/>
+          <p:cNvSpPr/>
+          <p:nvPr/>
+        </p:nvSpPr>
+        <p:spPr>
+          <a:xfrm>
+            <a:off x="7528255" y="347472"/>
+            <a:ext cx="4206240" cy="384048"/>
+          </a:xfrm>
+          <a:prstGeom prst="roundRect">
+            <a:avLst/>
+          </a:prstGeom>
+          <a:solidFill>
+            <a:srgbClr val="FFF19A"/>
+          </a:solidFill>
+          <a:ln w="12700">
+            <a:solidFill>
+              <a:srgbClr val="C89A00"/>
+            </a:solidFill>
+          </a:ln>
+          <a:effectLst/>
+        </p:spPr>
+        <p:style>
+          <a:lnRef idx="1">
+            <a:schemeClr val="accent1"/>
+          </a:lnRef>
+          <a:fillRef idx="3">
+            <a:schemeClr val="accent1"/>
+          </a:fillRef>
+          <a:effectRef idx="2">
+            <a:schemeClr val="accent1"/>
+          </a:effectRef>
+          <a:fontRef idx="minor">
+            <a:schemeClr val="lt1"/>
+          </a:fontRef>
+        </p:style>
+        <p:txBody>
+          <a:bodyPr rtlCol="0" anchor="ctr" wrap="square" lIns="73152" rIns="73152" tIns="18288" bIns="18288"/>
+          <a:lstStyle/>
+          <a:p>
+            <a:pPr algn="l"/>
+            <a:r>
+              <a:rPr sz="1000" b="1">
+                <a:solidFill>
+                  <a:srgbClr val="664D00"/>
+                </a:solidFill>
+                <a:latin typeface="맑은 고딕"/>
+              </a:rPr>
+              <a:t>📎 사진 첨부: BVSE bimodal 에너지 분포 / pathway 맵</a:t>
+            </a:r>
+          </a:p>
+        </p:txBody>
+      </p:sp>
     </p:spTree>
   </p:cSld>
   <p:clrMapOvr>
@@ -12547,6 +12987,61 @@
                 <a:latin typeface="맑은 고딕"/>
               </a:rPr>
               <a:t>18 / 21</a:t>
+            </a:r>
+          </a:p>
+        </p:txBody>
+      </p:sp>
+      <p:sp>
+        <p:nvSpPr>
+          <p:cNvPr id="12" name="Rounded Rectangle 11"/>
+          <p:cNvSpPr/>
+          <p:nvPr/>
+        </p:nvSpPr>
+        <p:spPr>
+          <a:xfrm>
+            <a:off x="7528255" y="347472"/>
+            <a:ext cx="4206240" cy="384048"/>
+          </a:xfrm>
+          <a:prstGeom prst="roundRect">
+            <a:avLst/>
+          </a:prstGeom>
+          <a:solidFill>
+            <a:srgbClr val="FFF19A"/>
+          </a:solidFill>
+          <a:ln w="12700">
+            <a:solidFill>
+              <a:srgbClr val="C89A00"/>
+            </a:solidFill>
+          </a:ln>
+          <a:effectLst/>
+        </p:spPr>
+        <p:style>
+          <a:lnRef idx="1">
+            <a:schemeClr val="accent1"/>
+          </a:lnRef>
+          <a:fillRef idx="3">
+            <a:schemeClr val="accent1"/>
+          </a:fillRef>
+          <a:effectRef idx="2">
+            <a:schemeClr val="accent1"/>
+          </a:effectRef>
+          <a:fontRef idx="minor">
+            <a:schemeClr val="lt1"/>
+          </a:fontRef>
+        </p:style>
+        <p:txBody>
+          <a:bodyPr rtlCol="0" anchor="ctr" wrap="square" lIns="73152" rIns="73152" tIns="18288" bIns="18288"/>
+          <a:lstStyle/>
+          <a:p>
+            <a:pPr algn="l"/>
+            <a:r>
+              <a:rPr sz="1000" b="1">
+                <a:solidFill>
+                  <a:srgbClr val="664D00"/>
+                </a:solidFill>
+                <a:latin typeface="맑은 고딕"/>
+              </a:rPr>
+              <a:t>📎 사진 첨부: ELF isosurface (PS₄ covalent + Li–anion ionic)</a:t>
             </a:r>
           </a:p>
         </p:txBody>
@@ -13352,6 +13847,61 @@
           </a:p>
         </p:txBody>
       </p:sp>
+      <p:sp>
+        <p:nvSpPr>
+          <p:cNvPr id="11" name="Rounded Rectangle 10"/>
+          <p:cNvSpPr/>
+          <p:nvPr/>
+        </p:nvSpPr>
+        <p:spPr>
+          <a:xfrm>
+            <a:off x="7528255" y="347472"/>
+            <a:ext cx="4206240" cy="384048"/>
+          </a:xfrm>
+          <a:prstGeom prst="roundRect">
+            <a:avLst/>
+          </a:prstGeom>
+          <a:solidFill>
+            <a:srgbClr val="FFF19A"/>
+          </a:solidFill>
+          <a:ln w="12700">
+            <a:solidFill>
+              <a:srgbClr val="C89A00"/>
+            </a:solidFill>
+          </a:ln>
+          <a:effectLst/>
+        </p:spPr>
+        <p:style>
+          <a:lnRef idx="1">
+            <a:schemeClr val="accent1"/>
+          </a:lnRef>
+          <a:fillRef idx="3">
+            <a:schemeClr val="accent1"/>
+          </a:fillRef>
+          <a:effectRef idx="2">
+            <a:schemeClr val="accent1"/>
+          </a:effectRef>
+          <a:fontRef idx="minor">
+            <a:schemeClr val="lt1"/>
+          </a:fontRef>
+        </p:style>
+        <p:txBody>
+          <a:bodyPr rtlCol="0" anchor="ctr" wrap="square" lIns="73152" rIns="73152" tIns="18288" bIns="18288"/>
+          <a:lstStyle/>
+          <a:p>
+            <a:pPr algn="l"/>
+            <a:r>
+              <a:rPr sz="1000" b="1">
+                <a:solidFill>
+                  <a:srgbClr val="664D00"/>
+                </a:solidFill>
+                <a:latin typeface="맑은 고딕"/>
+              </a:rPr>
+              <a:t>📎 사진 첨부: k-mesh / LOBSTER spilling / AIMD 수렴 plot</a:t>
+            </a:r>
+          </a:p>
+        </p:txBody>
+      </p:sp>
     </p:spTree>
   </p:cSld>
   <p:clrMapOvr>
@@ -14068,6 +14618,61 @@
           </a:p>
         </p:txBody>
       </p:sp>
+      <p:sp>
+        <p:nvSpPr>
+          <p:cNvPr id="19" name="Rounded Rectangle 18"/>
+          <p:cNvSpPr/>
+          <p:nvPr/>
+        </p:nvSpPr>
+        <p:spPr>
+          <a:xfrm>
+            <a:off x="7528255" y="347472"/>
+            <a:ext cx="4206240" cy="384048"/>
+          </a:xfrm>
+          <a:prstGeom prst="roundRect">
+            <a:avLst/>
+          </a:prstGeom>
+          <a:solidFill>
+            <a:srgbClr val="FFF19A"/>
+          </a:solidFill>
+          <a:ln w="12700">
+            <a:solidFill>
+              <a:srgbClr val="C89A00"/>
+            </a:solidFill>
+          </a:ln>
+          <a:effectLst/>
+        </p:spPr>
+        <p:style>
+          <a:lnRef idx="1">
+            <a:schemeClr val="accent1"/>
+          </a:lnRef>
+          <a:fillRef idx="3">
+            <a:schemeClr val="accent1"/>
+          </a:fillRef>
+          <a:effectRef idx="2">
+            <a:schemeClr val="accent1"/>
+          </a:effectRef>
+          <a:fontRef idx="minor">
+            <a:schemeClr val="lt1"/>
+          </a:fontRef>
+        </p:style>
+        <p:txBody>
+          <a:bodyPr rtlCol="0" anchor="ctr" wrap="square" lIns="73152" rIns="73152" tIns="18288" bIns="18288"/>
+          <a:lstStyle/>
+          <a:p>
+            <a:pPr algn="l"/>
+            <a:r>
+              <a:rPr sz="1000" b="1">
+                <a:solidFill>
+                  <a:srgbClr val="664D00"/>
+                </a:solidFill>
+                <a:latin typeface="맑은 고딕"/>
+              </a:rPr>
+              <a:t>📎 사진 첨부: LPSCl F-43m vs LPSCl₁.₆ R3m 결정구조 (VESTA, 동일 시점)</a:t>
+            </a:r>
+          </a:p>
+        </p:txBody>
+      </p:sp>
     </p:spTree>
   </p:cSld>
   <p:clrMapOvr>
@@ -15552,6 +16157,61 @@
           </a:p>
         </p:txBody>
       </p:sp>
+      <p:sp>
+        <p:nvSpPr>
+          <p:cNvPr id="11" name="Rounded Rectangle 10"/>
+          <p:cNvSpPr/>
+          <p:nvPr/>
+        </p:nvSpPr>
+        <p:spPr>
+          <a:xfrm>
+            <a:off x="7528255" y="347472"/>
+            <a:ext cx="4206240" cy="384048"/>
+          </a:xfrm>
+          <a:prstGeom prst="roundRect">
+            <a:avLst/>
+          </a:prstGeom>
+          <a:solidFill>
+            <a:srgbClr val="FFF19A"/>
+          </a:solidFill>
+          <a:ln w="12700">
+            <a:solidFill>
+              <a:srgbClr val="C89A00"/>
+            </a:solidFill>
+          </a:ln>
+          <a:effectLst/>
+        </p:spPr>
+        <p:style>
+          <a:lnRef idx="1">
+            <a:schemeClr val="accent1"/>
+          </a:lnRef>
+          <a:fillRef idx="3">
+            <a:schemeClr val="accent1"/>
+          </a:fillRef>
+          <a:effectRef idx="2">
+            <a:schemeClr val="accent1"/>
+          </a:effectRef>
+          <a:fontRef idx="minor">
+            <a:schemeClr val="lt1"/>
+          </a:fontRef>
+        </p:style>
+        <p:txBody>
+          <a:bodyPr rtlCol="0" anchor="ctr" wrap="square" lIns="73152" rIns="73152" tIns="18288" bIns="18288"/>
+          <a:lstStyle/>
+          <a:p>
+            <a:pPr algn="l"/>
+            <a:r>
+              <a:rPr sz="1000" b="1">
+                <a:solidFill>
+                  <a:srgbClr val="664D00"/>
+                </a:solidFill>
+                <a:latin typeface="맑은 고딕"/>
+              </a:rPr>
+              <a:t>📎 사진 첨부: 3-probe (BVSE · NEB · MD) 수렴 schematic</a:t>
+            </a:r>
+          </a:p>
+        </p:txBody>
+      </p:sp>
     </p:spTree>
   </p:cSld>
   <p:clrMapOvr>
@@ -16252,6 +16912,61 @@
           </a:p>
         </p:txBody>
       </p:sp>
+      <p:sp>
+        <p:nvSpPr>
+          <p:cNvPr id="8" name="Rounded Rectangle 7"/>
+          <p:cNvSpPr/>
+          <p:nvPr/>
+        </p:nvSpPr>
+        <p:spPr>
+          <a:xfrm>
+            <a:off x="7528255" y="347472"/>
+            <a:ext cx="4206240" cy="384048"/>
+          </a:xfrm>
+          <a:prstGeom prst="roundRect">
+            <a:avLst/>
+          </a:prstGeom>
+          <a:solidFill>
+            <a:srgbClr val="FFF19A"/>
+          </a:solidFill>
+          <a:ln w="12700">
+            <a:solidFill>
+              <a:srgbClr val="C89A00"/>
+            </a:solidFill>
+          </a:ln>
+          <a:effectLst/>
+        </p:spPr>
+        <p:style>
+          <a:lnRef idx="1">
+            <a:schemeClr val="accent1"/>
+          </a:lnRef>
+          <a:fillRef idx="3">
+            <a:schemeClr val="accent1"/>
+          </a:fillRef>
+          <a:effectRef idx="2">
+            <a:schemeClr val="accent1"/>
+          </a:effectRef>
+          <a:fontRef idx="minor">
+            <a:schemeClr val="lt1"/>
+          </a:fontRef>
+        </p:style>
+        <p:txBody>
+          <a:bodyPr rtlCol="0" anchor="ctr" wrap="square" lIns="73152" rIns="73152" tIns="18288" bIns="18288"/>
+          <a:lstStyle/>
+          <a:p>
+            <a:pPr algn="l"/>
+            <a:r>
+              <a:rPr sz="1000" b="1">
+                <a:solidFill>
+                  <a:srgbClr val="664D00"/>
+                </a:solidFill>
+                <a:latin typeface="맑은 고딕"/>
+              </a:rPr>
+              <a:t>📎 사진 첨부: Oxidation 4-axis radar 또는 grid</a:t>
+            </a:r>
+          </a:p>
+        </p:txBody>
+      </p:sp>
     </p:spTree>
   </p:cSld>
   <p:clrMapOvr>
@@ -17178,6 +17893,61 @@
                 <a:latin typeface="맑은 고딕"/>
               </a:rPr>
               <a:t>23 / 21</a:t>
+            </a:r>
+          </a:p>
+        </p:txBody>
+      </p:sp>
+      <p:sp>
+        <p:nvSpPr>
+          <p:cNvPr id="11" name="Rounded Rectangle 10"/>
+          <p:cNvSpPr/>
+          <p:nvPr/>
+        </p:nvSpPr>
+        <p:spPr>
+          <a:xfrm>
+            <a:off x="7528255" y="347472"/>
+            <a:ext cx="4206240" cy="384048"/>
+          </a:xfrm>
+          <a:prstGeom prst="roundRect">
+            <a:avLst/>
+          </a:prstGeom>
+          <a:solidFill>
+            <a:srgbClr val="FFF19A"/>
+          </a:solidFill>
+          <a:ln w="12700">
+            <a:solidFill>
+              <a:srgbClr val="C89A00"/>
+            </a:solidFill>
+          </a:ln>
+          <a:effectLst/>
+        </p:spPr>
+        <p:style>
+          <a:lnRef idx="1">
+            <a:schemeClr val="accent1"/>
+          </a:lnRef>
+          <a:fillRef idx="3">
+            <a:schemeClr val="accent1"/>
+          </a:fillRef>
+          <a:effectRef idx="2">
+            <a:schemeClr val="accent1"/>
+          </a:effectRef>
+          <a:fontRef idx="minor">
+            <a:schemeClr val="lt1"/>
+          </a:fontRef>
+        </p:style>
+        <p:txBody>
+          <a:bodyPr rtlCol="0" anchor="ctr" wrap="square" lIns="73152" rIns="73152" tIns="18288" bIns="18288"/>
+          <a:lstStyle/>
+          <a:p>
+            <a:pPr algn="l"/>
+            <a:r>
+              <a:rPr sz="1000" b="1">
+                <a:solidFill>
+                  <a:srgbClr val="664D00"/>
+                </a:solidFill>
+                <a:latin typeface="맑은 고딕"/>
+              </a:rPr>
+              <a:t>📎 사진 첨부: Constrained ESW Cl-scan + 분해반응 ΔG 막대</a:t>
             </a:r>
           </a:p>
         </p:txBody>
@@ -19407,6 +20177,61 @@
           </a:p>
         </p:txBody>
       </p:sp>
+      <p:sp>
+        <p:nvSpPr>
+          <p:cNvPr id="14" name="Rounded Rectangle 13"/>
+          <p:cNvSpPr/>
+          <p:nvPr/>
+        </p:nvSpPr>
+        <p:spPr>
+          <a:xfrm>
+            <a:off x="7528255" y="347472"/>
+            <a:ext cx="4206240" cy="384048"/>
+          </a:xfrm>
+          <a:prstGeom prst="roundRect">
+            <a:avLst/>
+          </a:prstGeom>
+          <a:solidFill>
+            <a:srgbClr val="FFF19A"/>
+          </a:solidFill>
+          <a:ln w="12700">
+            <a:solidFill>
+              <a:srgbClr val="C89A00"/>
+            </a:solidFill>
+          </a:ln>
+          <a:effectLst/>
+        </p:spPr>
+        <p:style>
+          <a:lnRef idx="1">
+            <a:schemeClr val="accent1"/>
+          </a:lnRef>
+          <a:fillRef idx="3">
+            <a:schemeClr val="accent1"/>
+          </a:fillRef>
+          <a:effectRef idx="2">
+            <a:schemeClr val="accent1"/>
+          </a:effectRef>
+          <a:fontRef idx="minor">
+            <a:schemeClr val="lt1"/>
+          </a:fontRef>
+        </p:style>
+        <p:txBody>
+          <a:bodyPr rtlCol="0" anchor="ctr" wrap="square" lIns="73152" rIns="73152" tIns="18288" bIns="18288"/>
+          <a:lstStyle/>
+          <a:p>
+            <a:pPr algn="l"/>
+            <a:r>
+              <a:rPr sz="1000" b="1">
+                <a:solidFill>
+                  <a:srgbClr val="664D00"/>
+                </a:solidFill>
+                <a:latin typeface="맑은 고딕"/>
+              </a:rPr>
+              <a:t>📎 사진 첨부: Trade-off 4축 + Paper #2 도핑 roadmap</a:t>
+            </a:r>
+          </a:p>
+        </p:txBody>
+      </p:sp>
     </p:spTree>
   </p:cSld>
   <p:clrMapOvr>
@@ -20206,6 +21031,61 @@
           </a:p>
         </p:txBody>
       </p:sp>
+      <p:sp>
+        <p:nvSpPr>
+          <p:cNvPr id="19" name="Rounded Rectangle 18"/>
+          <p:cNvSpPr/>
+          <p:nvPr/>
+        </p:nvSpPr>
+        <p:spPr>
+          <a:xfrm>
+            <a:off x="7528255" y="347472"/>
+            <a:ext cx="4206240" cy="384048"/>
+          </a:xfrm>
+          <a:prstGeom prst="roundRect">
+            <a:avLst/>
+          </a:prstGeom>
+          <a:solidFill>
+            <a:srgbClr val="FFF19A"/>
+          </a:solidFill>
+          <a:ln w="12700">
+            <a:solidFill>
+              <a:srgbClr val="C89A00"/>
+            </a:solidFill>
+          </a:ln>
+          <a:effectLst/>
+        </p:spPr>
+        <p:style>
+          <a:lnRef idx="1">
+            <a:schemeClr val="accent1"/>
+          </a:lnRef>
+          <a:fillRef idx="3">
+            <a:schemeClr val="accent1"/>
+          </a:fillRef>
+          <a:effectRef idx="2">
+            <a:schemeClr val="accent1"/>
+          </a:effectRef>
+          <a:fontRef idx="minor">
+            <a:schemeClr val="lt1"/>
+          </a:fontRef>
+        </p:style>
+        <p:txBody>
+          <a:bodyPr rtlCol="0" anchor="ctr" wrap="square" lIns="73152" rIns="73152" tIns="18288" bIns="18288"/>
+          <a:lstStyle/>
+          <a:p>
+            <a:pPr algn="l"/>
+            <a:r>
+              <a:rPr sz="1000" b="1">
+                <a:solidFill>
+                  <a:srgbClr val="664D00"/>
+                </a:solidFill>
+                <a:latin typeface="맑은 고딕"/>
+              </a:rPr>
+              <a:t>📎 사진 첨부: 3-tier pipeline 모식도 (선택)</a:t>
+            </a:r>
+          </a:p>
+        </p:txBody>
+      </p:sp>
     </p:spTree>
   </p:cSld>
   <p:clrMapOvr>
@@ -21367,6 +22247,61 @@
                 <a:latin typeface="맑은 고딕"/>
               </a:rPr>
               <a:t>4 / 21</a:t>
+            </a:r>
+          </a:p>
+        </p:txBody>
+      </p:sp>
+      <p:sp>
+        <p:nvSpPr>
+          <p:cNvPr id="9" name="Rounded Rectangle 8"/>
+          <p:cNvSpPr/>
+          <p:nvPr/>
+        </p:nvSpPr>
+        <p:spPr>
+          <a:xfrm>
+            <a:off x="7528255" y="347472"/>
+            <a:ext cx="4206240" cy="384048"/>
+          </a:xfrm>
+          <a:prstGeom prst="roundRect">
+            <a:avLst/>
+          </a:prstGeom>
+          <a:solidFill>
+            <a:srgbClr val="FFF19A"/>
+          </a:solidFill>
+          <a:ln w="12700">
+            <a:solidFill>
+              <a:srgbClr val="C89A00"/>
+            </a:solidFill>
+          </a:ln>
+          <a:effectLst/>
+        </p:spPr>
+        <p:style>
+          <a:lnRef idx="1">
+            <a:schemeClr val="accent1"/>
+          </a:lnRef>
+          <a:fillRef idx="3">
+            <a:schemeClr val="accent1"/>
+          </a:fillRef>
+          <a:effectRef idx="2">
+            <a:schemeClr val="accent1"/>
+          </a:effectRef>
+          <a:fontRef idx="minor">
+            <a:schemeClr val="lt1"/>
+          </a:fontRef>
+        </p:style>
+        <p:txBody>
+          <a:bodyPr rtlCol="0" anchor="ctr" wrap="square" lIns="73152" rIns="73152" tIns="18288" bIns="18288"/>
+          <a:lstStyle/>
+          <a:p>
+            <a:pPr algn="l"/>
+            <a:r>
+              <a:rPr sz="1000" b="1">
+                <a:solidFill>
+                  <a:srgbClr val="664D00"/>
+                </a:solidFill>
+                <a:latin typeface="맑은 고딕"/>
+              </a:rPr>
+              <a:t>📎 사진 첨부: 4-message at-a-glance figure</a:t>
             </a:r>
           </a:p>
         </p:txBody>
@@ -22320,6 +23255,61 @@
           </a:p>
         </p:txBody>
       </p:sp>
+      <p:sp>
+        <p:nvSpPr>
+          <p:cNvPr id="11" name="Rounded Rectangle 10"/>
+          <p:cNvSpPr/>
+          <p:nvPr/>
+        </p:nvSpPr>
+        <p:spPr>
+          <a:xfrm>
+            <a:off x="7528255" y="347472"/>
+            <a:ext cx="4206240" cy="384048"/>
+          </a:xfrm>
+          <a:prstGeom prst="roundRect">
+            <a:avLst/>
+          </a:prstGeom>
+          <a:solidFill>
+            <a:srgbClr val="FFF19A"/>
+          </a:solidFill>
+          <a:ln w="12700">
+            <a:solidFill>
+              <a:srgbClr val="C89A00"/>
+            </a:solidFill>
+          </a:ln>
+          <a:effectLst/>
+        </p:spPr>
+        <p:style>
+          <a:lnRef idx="1">
+            <a:schemeClr val="accent1"/>
+          </a:lnRef>
+          <a:fillRef idx="3">
+            <a:schemeClr val="accent1"/>
+          </a:fillRef>
+          <a:effectRef idx="2">
+            <a:schemeClr val="accent1"/>
+          </a:effectRef>
+          <a:fontRef idx="minor">
+            <a:schemeClr val="lt1"/>
+          </a:fontRef>
+        </p:style>
+        <p:txBody>
+          <a:bodyPr rtlCol="0" anchor="ctr" wrap="square" lIns="73152" rIns="73152" tIns="18288" bIns="18288"/>
+          <a:lstStyle/>
+          <a:p>
+            <a:pPr algn="l"/>
+            <a:r>
+              <a:rPr sz="1000" b="1">
+                <a:solidFill>
+                  <a:srgbClr val="664D00"/>
+                </a:solidFill>
+                <a:latin typeface="맑은 고딕"/>
+              </a:rPr>
+              <a:t>📎 사진 첨부: PDOS 비교 (comp1 vs modelc, atom-projected)</a:t>
+            </a:r>
+          </a:p>
+        </p:txBody>
+      </p:sp>
     </p:spTree>
   </p:cSld>
   <p:clrMapOvr>
@@ -23277,6 +24267,61 @@
           </a:p>
         </p:txBody>
       </p:sp>
+      <p:sp>
+        <p:nvSpPr>
+          <p:cNvPr id="12" name="Rounded Rectangle 11"/>
+          <p:cNvSpPr/>
+          <p:nvPr/>
+        </p:nvSpPr>
+        <p:spPr>
+          <a:xfrm>
+            <a:off x="7528255" y="347472"/>
+            <a:ext cx="4206240" cy="384048"/>
+          </a:xfrm>
+          <a:prstGeom prst="roundRect">
+            <a:avLst/>
+          </a:prstGeom>
+          <a:solidFill>
+            <a:srgbClr val="FFF19A"/>
+          </a:solidFill>
+          <a:ln w="12700">
+            <a:solidFill>
+              <a:srgbClr val="C89A00"/>
+            </a:solidFill>
+          </a:ln>
+          <a:effectLst/>
+        </p:spPr>
+        <p:style>
+          <a:lnRef idx="1">
+            <a:schemeClr val="accent1"/>
+          </a:lnRef>
+          <a:fillRef idx="3">
+            <a:schemeClr val="accent1"/>
+          </a:fillRef>
+          <a:effectRef idx="2">
+            <a:schemeClr val="accent1"/>
+          </a:effectRef>
+          <a:fontRef idx="minor">
+            <a:schemeClr val="lt1"/>
+          </a:fontRef>
+        </p:style>
+        <p:txBody>
+          <a:bodyPr rtlCol="0" anchor="ctr" wrap="square" lIns="73152" rIns="73152" tIns="18288" bIns="18288"/>
+          <a:lstStyle/>
+          <a:p>
+            <a:pPr algn="l"/>
+            <a:r>
+              <a:rPr sz="1000" b="1">
+                <a:solidFill>
+                  <a:srgbClr val="664D00"/>
+                </a:solidFill>
+                <a:latin typeface="맑은 고딕"/>
+              </a:rPr>
+              <a:t>📎 사진 첨부: σ(T) Arrhenius plot (paired 600/800/1000 K)</a:t>
+            </a:r>
+          </a:p>
+        </p:txBody>
+      </p:sp>
     </p:spTree>
   </p:cSld>
   <p:clrMapOvr>
@@ -23910,6 +24955,61 @@
           </a:p>
         </p:txBody>
       </p:sp>
+      <p:sp>
+        <p:nvSpPr>
+          <p:cNvPr id="15" name="Rounded Rectangle 14"/>
+          <p:cNvSpPr/>
+          <p:nvPr/>
+        </p:nvSpPr>
+        <p:spPr>
+          <a:xfrm>
+            <a:off x="7528255" y="347472"/>
+            <a:ext cx="4206240" cy="384048"/>
+          </a:xfrm>
+          <a:prstGeom prst="roundRect">
+            <a:avLst/>
+          </a:prstGeom>
+          <a:solidFill>
+            <a:srgbClr val="FFF19A"/>
+          </a:solidFill>
+          <a:ln w="12700">
+            <a:solidFill>
+              <a:srgbClr val="C89A00"/>
+            </a:solidFill>
+          </a:ln>
+          <a:effectLst/>
+        </p:spPr>
+        <p:style>
+          <a:lnRef idx="1">
+            <a:schemeClr val="accent1"/>
+          </a:lnRef>
+          <a:fillRef idx="3">
+            <a:schemeClr val="accent1"/>
+          </a:fillRef>
+          <a:effectRef idx="2">
+            <a:schemeClr val="accent1"/>
+          </a:effectRef>
+          <a:fontRef idx="minor">
+            <a:schemeClr val="lt1"/>
+          </a:fontRef>
+        </p:style>
+        <p:txBody>
+          <a:bodyPr rtlCol="0" anchor="ctr" wrap="square" lIns="73152" rIns="73152" tIns="18288" bIns="18288"/>
+          <a:lstStyle/>
+          <a:p>
+            <a:pPr algn="l"/>
+            <a:r>
+              <a:rPr sz="1000" b="1">
+                <a:solidFill>
+                  <a:srgbClr val="664D00"/>
+                </a:solidFill>
+                <a:latin typeface="맑은 고딕"/>
+              </a:rPr>
+              <a:t>📎 사진 첨부: D₀ vs Eₐ 산점도 또는 prefactor 비교 막대</a:t>
+            </a:r>
+          </a:p>
+        </p:txBody>
+      </p:sp>
     </p:spTree>
   </p:cSld>
   <p:clrMapOvr>
@@ -24494,6 +25594,61 @@
           </a:p>
         </p:txBody>
       </p:sp>
+      <p:sp>
+        <p:nvSpPr>
+          <p:cNvPr id="9" name="Rounded Rectangle 8"/>
+          <p:cNvSpPr/>
+          <p:nvPr/>
+        </p:nvSpPr>
+        <p:spPr>
+          <a:xfrm>
+            <a:off x="7528255" y="347472"/>
+            <a:ext cx="4206240" cy="384048"/>
+          </a:xfrm>
+          <a:prstGeom prst="roundRect">
+            <a:avLst/>
+          </a:prstGeom>
+          <a:solidFill>
+            <a:srgbClr val="FFF19A"/>
+          </a:solidFill>
+          <a:ln w="12700">
+            <a:solidFill>
+              <a:srgbClr val="C89A00"/>
+            </a:solidFill>
+          </a:ln>
+          <a:effectLst/>
+        </p:spPr>
+        <p:style>
+          <a:lnRef idx="1">
+            <a:schemeClr val="accent1"/>
+          </a:lnRef>
+          <a:fillRef idx="3">
+            <a:schemeClr val="accent1"/>
+          </a:fillRef>
+          <a:effectRef idx="2">
+            <a:schemeClr val="accent1"/>
+          </a:effectRef>
+          <a:fontRef idx="minor">
+            <a:schemeClr val="lt1"/>
+          </a:fontRef>
+        </p:style>
+        <p:txBody>
+          <a:bodyPr rtlCol="0" anchor="ctr" wrap="square" lIns="73152" rIns="73152" tIns="18288" bIns="18288"/>
+          <a:lstStyle/>
+          <a:p>
+            <a:pPr algn="l"/>
+            <a:r>
+              <a:rPr sz="1000" b="1">
+                <a:solidFill>
+                  <a:srgbClr val="664D00"/>
+                </a:solidFill>
+                <a:latin typeface="맑은 고딕"/>
+              </a:rPr>
+              <a:t>📎 사진 첨부: Disorder ensemble Eₐ 분포 (matched-d 그룹)</a:t>
+            </a:r>
+          </a:p>
+        </p:txBody>
+      </p:sp>
     </p:spTree>
   </p:cSld>
   <p:clrMapOvr>
@@ -25653,6 +26808,61 @@
                 <a:latin typeface="맑은 고딕"/>
               </a:rPr>
               <a:t>9 / 21</a:t>
+            </a:r>
+          </a:p>
+        </p:txBody>
+      </p:sp>
+      <p:sp>
+        <p:nvSpPr>
+          <p:cNvPr id="8" name="Rounded Rectangle 7"/>
+          <p:cNvSpPr/>
+          <p:nvPr/>
+        </p:nvSpPr>
+        <p:spPr>
+          <a:xfrm>
+            <a:off x="7528255" y="347472"/>
+            <a:ext cx="4206240" cy="384048"/>
+          </a:xfrm>
+          <a:prstGeom prst="roundRect">
+            <a:avLst/>
+          </a:prstGeom>
+          <a:solidFill>
+            <a:srgbClr val="FFF19A"/>
+          </a:solidFill>
+          <a:ln w="12700">
+            <a:solidFill>
+              <a:srgbClr val="C89A00"/>
+            </a:solidFill>
+          </a:ln>
+          <a:effectLst/>
+        </p:spPr>
+        <p:style>
+          <a:lnRef idx="1">
+            <a:schemeClr val="accent1"/>
+          </a:lnRef>
+          <a:fillRef idx="3">
+            <a:schemeClr val="accent1"/>
+          </a:fillRef>
+          <a:effectRef idx="2">
+            <a:schemeClr val="accent1"/>
+          </a:effectRef>
+          <a:fontRef idx="minor">
+            <a:schemeClr val="lt1"/>
+          </a:fontRef>
+        </p:style>
+        <p:txBody>
+          <a:bodyPr rtlCol="0" anchor="ctr" wrap="square" lIns="73152" rIns="73152" tIns="18288" bIns="18288"/>
+          <a:lstStyle/>
+          <a:p>
+            <a:pPr algn="l"/>
+            <a:r>
+              <a:rPr sz="1000" b="1">
+                <a:solidFill>
+                  <a:srgbClr val="664D00"/>
+                </a:solidFill>
+                <a:latin typeface="맑은 고딕"/>
+              </a:rPr>
+              <a:t>📎 사진 첨부: σ(T) 저온 외삽 plot (300 K까지)</a:t>
             </a:r>
           </a:p>
         </p:txBody>

</xml_diff>

<commit_message>
seminar: rebuild PPT after visual QA (render-verified)
Rendered every slide via LibreOffice and fixed all layout defects:
- fig chips moved above the title baseline (long titles were covered)
- chip labels shortened to one line, 9pt centered
- slide 3 / ELF slide takeaways no longer collide with the footer
- balanced column widths for the #-tables (8b, 20, 21)
- footer page total corrected to 26

https://claude.ai/code/session_018pDuSCy524WqJCVpWjX7nn
</commit_message>
<xml_diff>
--- a/kb/papers/lpscl_vs_lpscl16_seminar_v1.pptx
+++ b/kb/papers/lpscl_vs_lpscl16_seminar_v1.pptx
@@ -4580,7 +4580,7 @@
                 </a:solidFill>
                 <a:latin typeface="맑은 고딕"/>
               </a:rPr>
-              <a:t>10 / 21</a:t>
+              <a:t>10 / 26</a:t>
             </a:r>
           </a:p>
         </p:txBody>
@@ -4593,8 +4593,8 @@
         </p:nvSpPr>
         <p:spPr>
           <a:xfrm>
-            <a:off x="7528255" y="347472"/>
-            <a:ext cx="4206240" cy="384048"/>
+            <a:off x="6933895" y="27432"/>
+            <a:ext cx="5120640" cy="274320"/>
           </a:xfrm>
           <a:prstGeom prst="roundRect">
             <a:avLst/>
@@ -4624,18 +4624,18 @@
           </a:fontRef>
         </p:style>
         <p:txBody>
-          <a:bodyPr rtlCol="0" anchor="ctr" wrap="square" lIns="73152" rIns="73152" tIns="18288" bIns="18288"/>
-          <a:lstStyle/>
-          <a:p>
-            <a:pPr algn="l"/>
-            <a:r>
-              <a:rPr sz="1000" b="1">
+          <a:bodyPr rtlCol="0" anchor="ctr" wrap="none" lIns="73152" rIns="73152" tIns="9144" bIns="9144"/>
+          <a:lstStyle/>
+          <a:p>
+            <a:pPr algn="ctr"/>
+            <a:r>
+              <a:rPr sz="900" b="1">
                 <a:solidFill>
                   <a:srgbClr val="664D00"/>
                 </a:solidFill>
                 <a:latin typeface="맑은 고딕"/>
               </a:rPr>
-              <a:t>📎 사진 첨부: Cohesive / Li–anion ionic glue 모식도 또는 막대</a:t>
+              <a:t>📎 사진 첨부: Li–anion ionic glue 막대/모식도</a:t>
             </a:r>
           </a:p>
         </p:txBody>
@@ -5968,7 +5968,7 @@
                 </a:solidFill>
                 <a:latin typeface="맑은 고딕"/>
               </a:rPr>
-              <a:t>11 / 21</a:t>
+              <a:t>11 / 26</a:t>
             </a:r>
           </a:p>
         </p:txBody>
@@ -5981,8 +5981,8 @@
         </p:nvSpPr>
         <p:spPr>
           <a:xfrm>
-            <a:off x="7528255" y="347472"/>
-            <a:ext cx="4206240" cy="384048"/>
+            <a:off x="6933895" y="27432"/>
+            <a:ext cx="5120640" cy="274320"/>
           </a:xfrm>
           <a:prstGeom prst="roundRect">
             <a:avLst/>
@@ -6012,18 +6012,18 @@
           </a:fontRef>
         </p:style>
         <p:txBody>
-          <a:bodyPr rtlCol="0" anchor="ctr" wrap="square" lIns="73152" rIns="73152" tIns="18288" bIns="18288"/>
-          <a:lstStyle/>
-          <a:p>
-            <a:pPr algn="l"/>
-            <a:r>
-              <a:rPr sz="1000" b="1">
+          <a:bodyPr rtlCol="0" anchor="ctr" wrap="none" lIns="73152" rIns="73152" tIns="9144" bIns="9144"/>
+          <a:lstStyle/>
+          <a:p>
+            <a:pPr algn="ctr"/>
+            <a:r>
+              <a:rPr sz="900" b="1">
                 <a:solidFill>
                   <a:srgbClr val="664D00"/>
                 </a:solidFill>
                 <a:latin typeface="맑은 고딕"/>
               </a:rPr>
-              <a:t>📎 사진 첨부: Elastic moduli (B, G, E) clamped vs relaxed 비교 막대</a:t>
+              <a:t>📎 사진 첨부: B·G·E clamped vs relaxed 막대</a:t>
             </a:r>
           </a:p>
         </p:txBody>
@@ -7015,7 +7015,7 @@
                 </a:solidFill>
                 <a:latin typeface="맑은 고딕"/>
               </a:rPr>
-              <a:t>12 / 21</a:t>
+              <a:t>12 / 26</a:t>
             </a:r>
           </a:p>
         </p:txBody>
@@ -7028,8 +7028,8 @@
         </p:nvSpPr>
         <p:spPr>
           <a:xfrm>
-            <a:off x="7528255" y="347472"/>
-            <a:ext cx="4206240" cy="384048"/>
+            <a:off x="6933895" y="27432"/>
+            <a:ext cx="5120640" cy="274320"/>
           </a:xfrm>
           <a:prstGeom prst="roundRect">
             <a:avLst/>
@@ -7059,12 +7059,12 @@
           </a:fontRef>
         </p:style>
         <p:txBody>
-          <a:bodyPr rtlCol="0" anchor="ctr" wrap="square" lIns="73152" rIns="73152" tIns="18288" bIns="18288"/>
-          <a:lstStyle/>
-          <a:p>
-            <a:pPr algn="l"/>
-            <a:r>
-              <a:rPr sz="1000" b="1">
+          <a:bodyPr rtlCol="0" anchor="ctr" wrap="none" lIns="73152" rIns="73152" tIns="9144" bIns="9144"/>
+          <a:lstStyle/>
+          <a:p>
+            <a:pPr algn="ctr"/>
+            <a:r>
+              <a:rPr sz="900" b="1">
                 <a:solidFill>
                   <a:srgbClr val="664D00"/>
                 </a:solidFill>
@@ -7191,11 +7191,11 @@
                 <a:tableStyleId>{5C22544A-7EE6-4342-B048-85BDC9FD1C3A}</a:tableStyleId>
               </a:tblPr>
               <a:tblGrid>
-                <a:gridCol w="2267712"/>
-                <a:gridCol w="2267712"/>
-                <a:gridCol w="2267712"/>
-                <a:gridCol w="2267712"/>
-                <a:gridCol w="2267712"/>
+                <a:gridCol w="548640"/>
+                <a:gridCol w="3840480"/>
+                <a:gridCol w="2286000"/>
+                <a:gridCol w="2286000"/>
+                <a:gridCol w="2377440"/>
               </a:tblGrid>
               <a:tr h="822960">
                 <a:tc>
@@ -7870,7 +7870,7 @@
                 </a:solidFill>
                 <a:latin typeface="맑은 고딕"/>
               </a:rPr>
-              <a:t>13 / 21</a:t>
+              <a:t>13 / 26</a:t>
             </a:r>
           </a:p>
         </p:txBody>
@@ -7883,8 +7883,8 @@
         </p:nvSpPr>
         <p:spPr>
           <a:xfrm>
-            <a:off x="7528255" y="347472"/>
-            <a:ext cx="4206240" cy="384048"/>
+            <a:off x="6933895" y="27432"/>
+            <a:ext cx="5120640" cy="274320"/>
           </a:xfrm>
           <a:prstGeom prst="roundRect">
             <a:avLst/>
@@ -7914,18 +7914,18 @@
           </a:fontRef>
         </p:style>
         <p:txBody>
-          <a:bodyPr rtlCol="0" anchor="ctr" wrap="square" lIns="73152" rIns="73152" tIns="18288" bIns="18288"/>
-          <a:lstStyle/>
-          <a:p>
-            <a:pPr algn="l"/>
-            <a:r>
-              <a:rPr sz="1000" b="1">
+          <a:bodyPr rtlCol="0" anchor="ctr" wrap="none" lIns="73152" rIns="73152" tIns="9144" bIns="9144"/>
+          <a:lstStyle/>
+          <a:p>
+            <a:pPr algn="ctr"/>
+            <a:r>
+              <a:rPr sz="900" b="1">
                 <a:solidFill>
                   <a:srgbClr val="664D00"/>
                 </a:solidFill>
                 <a:latin typeface="맑은 고딕"/>
               </a:rPr>
-              <a:t>📎 사진 첨부: M4 4 cross-check 수렴 그림</a:t>
+              <a:t>📎 사진 첨부: M4 cross-check 수렴 그림</a:t>
             </a:r>
           </a:p>
         </p:txBody>
@@ -8934,7 +8934,7 @@
                 </a:solidFill>
                 <a:latin typeface="맑은 고딕"/>
               </a:rPr>
-              <a:t>14 / 21</a:t>
+              <a:t>14 / 26</a:t>
             </a:r>
           </a:p>
         </p:txBody>
@@ -8947,8 +8947,8 @@
         </p:nvSpPr>
         <p:spPr>
           <a:xfrm>
-            <a:off x="7528255" y="347472"/>
-            <a:ext cx="4206240" cy="384048"/>
+            <a:off x="6933895" y="27432"/>
+            <a:ext cx="5120640" cy="274320"/>
           </a:xfrm>
           <a:prstGeom prst="roundRect">
             <a:avLst/>
@@ -8978,18 +8978,18 @@
           </a:fontRef>
         </p:style>
         <p:txBody>
-          <a:bodyPr rtlCol="0" anchor="ctr" wrap="square" lIns="73152" rIns="73152" tIns="18288" bIns="18288"/>
-          <a:lstStyle/>
-          <a:p>
-            <a:pPr algn="l"/>
-            <a:r>
-              <a:rPr sz="1000" b="1">
+          <a:bodyPr rtlCol="0" anchor="ctr" wrap="none" lIns="73152" rIns="73152" tIns="9144" bIns="9144"/>
+          <a:lstStyle/>
+          <a:p>
+            <a:pPr algn="ctr"/>
+            <a:r>
+              <a:rPr sz="900" b="1">
                 <a:solidFill>
                   <a:srgbClr val="664D00"/>
                 </a:solidFill>
                 <a:latin typeface="맑은 고딕"/>
               </a:rPr>
-              <a:t>📎 사진 첨부: PS₄ 결합 길이/각도 히스토그램 (두 시스템 overlay)</a:t>
+              <a:t>📎 사진 첨부: PS₄ 결합 히스토그램 overlay</a:t>
             </a:r>
           </a:p>
         </p:txBody>
@@ -10154,7 +10154,7 @@
                 </a:solidFill>
                 <a:latin typeface="맑은 고딕"/>
               </a:rPr>
-              <a:t>15 / 21</a:t>
+              <a:t>15 / 26</a:t>
             </a:r>
           </a:p>
         </p:txBody>
@@ -10167,8 +10167,8 @@
         </p:nvSpPr>
         <p:spPr>
           <a:xfrm>
-            <a:off x="7528255" y="347472"/>
-            <a:ext cx="4206240" cy="384048"/>
+            <a:off x="6933895" y="27432"/>
+            <a:ext cx="5120640" cy="274320"/>
           </a:xfrm>
           <a:prstGeom prst="roundRect">
             <a:avLst/>
@@ -10198,18 +10198,18 @@
           </a:fontRef>
         </p:style>
         <p:txBody>
-          <a:bodyPr rtlCol="0" anchor="ctr" wrap="square" lIns="73152" rIns="73152" tIns="18288" bIns="18288"/>
-          <a:lstStyle/>
-          <a:p>
-            <a:pPr algn="l"/>
-            <a:r>
-              <a:rPr sz="1000" b="1">
+          <a:bodyPr rtlCol="0" anchor="ctr" wrap="none" lIns="73152" rIns="73152" tIns="9144" bIns="9144"/>
+          <a:lstStyle/>
+          <a:p>
+            <a:pPr algn="ctr"/>
+            <a:r>
+              <a:rPr sz="900" b="1">
                 <a:solidFill>
                   <a:srgbClr val="664D00"/>
                 </a:solidFill>
                 <a:latin typeface="맑은 고딕"/>
               </a:rPr>
-              <a:t>📎 사진 첨부: Li–Cl per-bond 히스토그램 (4a vs 4d-AS 분리)</a:t>
+              <a:t>📎 사진 첨부: Li–Cl per-bond 히스토그램 (4a/4d)</a:t>
             </a:r>
           </a:p>
         </p:txBody>
@@ -11150,7 +11150,7 @@
                 </a:solidFill>
                 <a:latin typeface="맑은 고딕"/>
               </a:rPr>
-              <a:t>16 / 21</a:t>
+              <a:t>16 / 26</a:t>
             </a:r>
           </a:p>
         </p:txBody>
@@ -11163,8 +11163,8 @@
         </p:nvSpPr>
         <p:spPr>
           <a:xfrm>
-            <a:off x="7528255" y="347472"/>
-            <a:ext cx="4206240" cy="384048"/>
+            <a:off x="6933895" y="27432"/>
+            <a:ext cx="5120640" cy="274320"/>
           </a:xfrm>
           <a:prstGeom prst="roundRect">
             <a:avLst/>
@@ -11194,18 +11194,18 @@
           </a:fontRef>
         </p:style>
         <p:txBody>
-          <a:bodyPr rtlCol="0" anchor="ctr" wrap="square" lIns="73152" rIns="73152" tIns="18288" bIns="18288"/>
-          <a:lstStyle/>
-          <a:p>
-            <a:pPr algn="l"/>
-            <a:r>
-              <a:rPr sz="1000" b="1">
+          <a:bodyPr rtlCol="0" anchor="ctr" wrap="none" lIns="73152" rIns="73152" tIns="9144" bIns="9144"/>
+          <a:lstStyle/>
+          <a:p>
+            <a:pPr algn="ctr"/>
+            <a:r>
+              <a:rPr sz="900" b="1">
                 <a:solidFill>
                   <a:srgbClr val="664D00"/>
                 </a:solidFill>
                 <a:latin typeface="맑은 고딕"/>
               </a:rPr>
-              <a:t>📎 사진 첨부: Voronoi 4-sublattice 모식도 (4a/4b/4c/4d)</a:t>
+              <a:t>📎 사진 첨부: Voronoi 4-sublattice 모식도</a:t>
             </a:r>
           </a:p>
         </p:txBody>
@@ -12135,7 +12135,7 @@
                 </a:solidFill>
                 <a:latin typeface="맑은 고딕"/>
               </a:rPr>
-              <a:t>17 / 21</a:t>
+              <a:t>17 / 26</a:t>
             </a:r>
           </a:p>
         </p:txBody>
@@ -12148,8 +12148,8 @@
         </p:nvSpPr>
         <p:spPr>
           <a:xfrm>
-            <a:off x="7528255" y="347472"/>
-            <a:ext cx="4206240" cy="384048"/>
+            <a:off x="6933895" y="27432"/>
+            <a:ext cx="5120640" cy="274320"/>
           </a:xfrm>
           <a:prstGeom prst="roundRect">
             <a:avLst/>
@@ -12179,18 +12179,18 @@
           </a:fontRef>
         </p:style>
         <p:txBody>
-          <a:bodyPr rtlCol="0" anchor="ctr" wrap="square" lIns="73152" rIns="73152" tIns="18288" bIns="18288"/>
-          <a:lstStyle/>
-          <a:p>
-            <a:pPr algn="l"/>
-            <a:r>
-              <a:rPr sz="1000" b="1">
+          <a:bodyPr rtlCol="0" anchor="ctr" wrap="none" lIns="73152" rIns="73152" tIns="9144" bIns="9144"/>
+          <a:lstStyle/>
+          <a:p>
+            <a:pPr algn="ctr"/>
+            <a:r>
+              <a:rPr sz="900" b="1">
                 <a:solidFill>
                   <a:srgbClr val="664D00"/>
                 </a:solidFill>
                 <a:latin typeface="맑은 고딕"/>
               </a:rPr>
-              <a:t>📎 사진 첨부: BVSE bimodal 에너지 분포 / pathway 맵</a:t>
+              <a:t>📎 사진 첨부: BVSE bimodal 분포 / pathway 맵</a:t>
             </a:r>
           </a:p>
         </p:txBody>
@@ -12507,8 +12507,8 @@
           <p:nvPr/>
         </p:nvGraphicFramePr>
         <p:xfrm>
-          <a:off x="457200" y="4663440"/>
-          <a:ext cx="11338560" cy="1554480"/>
+          <a:off x="457200" y="4617720"/>
+          <a:ext cx="11338560" cy="1417320"/>
         </p:xfrm>
         <a:graphic>
           <a:graphicData uri="http://schemas.openxmlformats.org/drawingml/2006/table">
@@ -12522,7 +12522,7 @@
                 <a:gridCol w="2834640"/>
                 <a:gridCol w="2834640"/>
               </a:tblGrid>
-              <a:tr h="388620">
+              <a:tr h="354330">
                 <a:tc>
                   <a:txBody>
                     <a:bodyPr lIns="54864" rIns="54864" tIns="18288" bIns="18288"/>
@@ -12612,7 +12612,7 @@
                   </a:tcPr>
                 </a:tc>
               </a:tr>
-              <a:tr h="388620">
+              <a:tr h="354330">
                 <a:tc>
                   <a:txBody>
                     <a:bodyPr lIns="54864" rIns="54864" tIns="18288" bIns="18288"/>
@@ -12702,7 +12702,7 @@
                   </a:tcPr>
                 </a:tc>
               </a:tr>
-              <a:tr h="388620">
+              <a:tr h="354330">
                 <a:tc>
                   <a:txBody>
                     <a:bodyPr lIns="54864" rIns="54864" tIns="18288" bIns="18288"/>
@@ -12792,7 +12792,7 @@
                   </a:tcPr>
                 </a:tc>
               </a:tr>
-              <a:tr h="388620">
+              <a:tr h="354330">
                 <a:tc>
                   <a:txBody>
                     <a:bodyPr lIns="54864" rIns="54864" tIns="18288" bIns="18288"/>
@@ -12894,7 +12894,7 @@
         </p:nvSpPr>
         <p:spPr>
           <a:xfrm>
-            <a:off x="457200" y="6309360"/>
+            <a:off x="457200" y="6108192"/>
             <a:ext cx="11338560" cy="274320"/>
           </a:xfrm>
           <a:prstGeom prst="rect">
@@ -12986,7 +12986,7 @@
                 </a:solidFill>
                 <a:latin typeface="맑은 고딕"/>
               </a:rPr>
-              <a:t>18 / 21</a:t>
+              <a:t>18 / 26</a:t>
             </a:r>
           </a:p>
         </p:txBody>
@@ -12999,8 +12999,8 @@
         </p:nvSpPr>
         <p:spPr>
           <a:xfrm>
-            <a:off x="7528255" y="347472"/>
-            <a:ext cx="4206240" cy="384048"/>
+            <a:off x="6933895" y="27432"/>
+            <a:ext cx="5120640" cy="274320"/>
           </a:xfrm>
           <a:prstGeom prst="roundRect">
             <a:avLst/>
@@ -13030,18 +13030,18 @@
           </a:fontRef>
         </p:style>
         <p:txBody>
-          <a:bodyPr rtlCol="0" anchor="ctr" wrap="square" lIns="73152" rIns="73152" tIns="18288" bIns="18288"/>
-          <a:lstStyle/>
-          <a:p>
-            <a:pPr algn="l"/>
-            <a:r>
-              <a:rPr sz="1000" b="1">
+          <a:bodyPr rtlCol="0" anchor="ctr" wrap="none" lIns="73152" rIns="73152" tIns="9144" bIns="9144"/>
+          <a:lstStyle/>
+          <a:p>
+            <a:pPr algn="ctr"/>
+            <a:r>
+              <a:rPr sz="900" b="1">
                 <a:solidFill>
                   <a:srgbClr val="664D00"/>
                 </a:solidFill>
                 <a:latin typeface="맑은 고딕"/>
               </a:rPr>
-              <a:t>📎 사진 첨부: ELF isosurface (PS₄ covalent + Li–anion ionic)</a:t>
+              <a:t>📎 사진 첨부: ELF isosurface (covalent+ionic)</a:t>
             </a:r>
           </a:p>
         </p:txBody>
@@ -13842,7 +13842,7 @@
                 </a:solidFill>
                 <a:latin typeface="맑은 고딕"/>
               </a:rPr>
-              <a:t>19 / 21</a:t>
+              <a:t>19 / 26</a:t>
             </a:r>
           </a:p>
         </p:txBody>
@@ -13855,8 +13855,8 @@
         </p:nvSpPr>
         <p:spPr>
           <a:xfrm>
-            <a:off x="7528255" y="347472"/>
-            <a:ext cx="4206240" cy="384048"/>
+            <a:off x="6933895" y="27432"/>
+            <a:ext cx="5120640" cy="274320"/>
           </a:xfrm>
           <a:prstGeom prst="roundRect">
             <a:avLst/>
@@ -13886,18 +13886,18 @@
           </a:fontRef>
         </p:style>
         <p:txBody>
-          <a:bodyPr rtlCol="0" anchor="ctr" wrap="square" lIns="73152" rIns="73152" tIns="18288" bIns="18288"/>
-          <a:lstStyle/>
-          <a:p>
-            <a:pPr algn="l"/>
-            <a:r>
-              <a:rPr sz="1000" b="1">
+          <a:bodyPr rtlCol="0" anchor="ctr" wrap="none" lIns="73152" rIns="73152" tIns="9144" bIns="9144"/>
+          <a:lstStyle/>
+          <a:p>
+            <a:pPr algn="ctr"/>
+            <a:r>
+              <a:rPr sz="900" b="1">
                 <a:solidFill>
                   <a:srgbClr val="664D00"/>
                 </a:solidFill>
                 <a:latin typeface="맑은 고딕"/>
               </a:rPr>
-              <a:t>📎 사진 첨부: k-mesh / LOBSTER spilling / AIMD 수렴 plot</a:t>
+              <a:t>📎 사진 첨부: k-mesh / spilling / AIMD 수렴</a:t>
             </a:r>
           </a:p>
         </p:txBody>
@@ -14613,7 +14613,7 @@
                 </a:solidFill>
                 <a:latin typeface="맑은 고딕"/>
               </a:rPr>
-              <a:t>2 / 21</a:t>
+              <a:t>2 / 26</a:t>
             </a:r>
           </a:p>
         </p:txBody>
@@ -14626,8 +14626,8 @@
         </p:nvSpPr>
         <p:spPr>
           <a:xfrm>
-            <a:off x="7528255" y="347472"/>
-            <a:ext cx="4206240" cy="384048"/>
+            <a:off x="6933895" y="27432"/>
+            <a:ext cx="5120640" cy="274320"/>
           </a:xfrm>
           <a:prstGeom prst="roundRect">
             <a:avLst/>
@@ -14657,18 +14657,18 @@
           </a:fontRef>
         </p:style>
         <p:txBody>
-          <a:bodyPr rtlCol="0" anchor="ctr" wrap="square" lIns="73152" rIns="73152" tIns="18288" bIns="18288"/>
-          <a:lstStyle/>
-          <a:p>
-            <a:pPr algn="l"/>
-            <a:r>
-              <a:rPr sz="1000" b="1">
+          <a:bodyPr rtlCol="0" anchor="ctr" wrap="none" lIns="73152" rIns="73152" tIns="9144" bIns="9144"/>
+          <a:lstStyle/>
+          <a:p>
+            <a:pPr algn="ctr"/>
+            <a:r>
+              <a:rPr sz="900" b="1">
                 <a:solidFill>
                   <a:srgbClr val="664D00"/>
                 </a:solidFill>
                 <a:latin typeface="맑은 고딕"/>
               </a:rPr>
-              <a:t>📎 사진 첨부: LPSCl F-43m vs LPSCl₁.₆ R3m 결정구조 (VESTA, 동일 시점)</a:t>
+              <a:t>📎 사진 첨부: 결정구조 VESTA (F-43m vs R3m)</a:t>
             </a:r>
           </a:p>
         </p:txBody>
@@ -15421,7 +15421,7 @@
                 </a:solidFill>
                 <a:latin typeface="맑은 고딕"/>
               </a:rPr>
-              <a:t>20 / 21</a:t>
+              <a:t>20 / 26</a:t>
             </a:r>
           </a:p>
         </p:txBody>
@@ -16152,7 +16152,7 @@
                 </a:solidFill>
                 <a:latin typeface="맑은 고딕"/>
               </a:rPr>
-              <a:t>21 / 21</a:t>
+              <a:t>21 / 26</a:t>
             </a:r>
           </a:p>
         </p:txBody>
@@ -16165,8 +16165,8 @@
         </p:nvSpPr>
         <p:spPr>
           <a:xfrm>
-            <a:off x="7528255" y="347472"/>
-            <a:ext cx="4206240" cy="384048"/>
+            <a:off x="6933895" y="27432"/>
+            <a:ext cx="5120640" cy="274320"/>
           </a:xfrm>
           <a:prstGeom prst="roundRect">
             <a:avLst/>
@@ -16196,18 +16196,18 @@
           </a:fontRef>
         </p:style>
         <p:txBody>
-          <a:bodyPr rtlCol="0" anchor="ctr" wrap="square" lIns="73152" rIns="73152" tIns="18288" bIns="18288"/>
-          <a:lstStyle/>
-          <a:p>
-            <a:pPr algn="l"/>
-            <a:r>
-              <a:rPr sz="1000" b="1">
+          <a:bodyPr rtlCol="0" anchor="ctr" wrap="none" lIns="73152" rIns="73152" tIns="9144" bIns="9144"/>
+          <a:lstStyle/>
+          <a:p>
+            <a:pPr algn="ctr"/>
+            <a:r>
+              <a:rPr sz="900" b="1">
                 <a:solidFill>
                   <a:srgbClr val="664D00"/>
                 </a:solidFill>
                 <a:latin typeface="맑은 고딕"/>
               </a:rPr>
-              <a:t>📎 사진 첨부: 3-probe (BVSE · NEB · MD) 수렴 schematic</a:t>
+              <a:t>📎 사진 첨부: 3-probe 수렴 schematic</a:t>
             </a:r>
           </a:p>
         </p:txBody>
@@ -16907,7 +16907,7 @@
                 </a:solidFill>
                 <a:latin typeface="맑은 고딕"/>
               </a:rPr>
-              <a:t>22 / 21</a:t>
+              <a:t>22 / 26</a:t>
             </a:r>
           </a:p>
         </p:txBody>
@@ -16920,8 +16920,8 @@
         </p:nvSpPr>
         <p:spPr>
           <a:xfrm>
-            <a:off x="7528255" y="347472"/>
-            <a:ext cx="4206240" cy="384048"/>
+            <a:off x="6933895" y="27432"/>
+            <a:ext cx="5120640" cy="274320"/>
           </a:xfrm>
           <a:prstGeom prst="roundRect">
             <a:avLst/>
@@ -16951,18 +16951,18 @@
           </a:fontRef>
         </p:style>
         <p:txBody>
-          <a:bodyPr rtlCol="0" anchor="ctr" wrap="square" lIns="73152" rIns="73152" tIns="18288" bIns="18288"/>
-          <a:lstStyle/>
-          <a:p>
-            <a:pPr algn="l"/>
-            <a:r>
-              <a:rPr sz="1000" b="1">
+          <a:bodyPr rtlCol="0" anchor="ctr" wrap="none" lIns="73152" rIns="73152" tIns="9144" bIns="9144"/>
+          <a:lstStyle/>
+          <a:p>
+            <a:pPr algn="ctr"/>
+            <a:r>
+              <a:rPr sz="900" b="1">
                 <a:solidFill>
                   <a:srgbClr val="664D00"/>
                 </a:solidFill>
                 <a:latin typeface="맑은 고딕"/>
               </a:rPr>
-              <a:t>📎 사진 첨부: Oxidation 4-axis radar 또는 grid</a:t>
+              <a:t>📎 사진 첨부: Oxidation 4-axis radar/grid</a:t>
             </a:r>
           </a:p>
         </p:txBody>
@@ -17892,7 +17892,7 @@
                 </a:solidFill>
                 <a:latin typeface="맑은 고딕"/>
               </a:rPr>
-              <a:t>23 / 21</a:t>
+              <a:t>23 / 26</a:t>
             </a:r>
           </a:p>
         </p:txBody>
@@ -17905,8 +17905,8 @@
         </p:nvSpPr>
         <p:spPr>
           <a:xfrm>
-            <a:off x="7528255" y="347472"/>
-            <a:ext cx="4206240" cy="384048"/>
+            <a:off x="6933895" y="27432"/>
+            <a:ext cx="5120640" cy="274320"/>
           </a:xfrm>
           <a:prstGeom prst="roundRect">
             <a:avLst/>
@@ -17936,18 +17936,18 @@
           </a:fontRef>
         </p:style>
         <p:txBody>
-          <a:bodyPr rtlCol="0" anchor="ctr" wrap="square" lIns="73152" rIns="73152" tIns="18288" bIns="18288"/>
-          <a:lstStyle/>
-          <a:p>
-            <a:pPr algn="l"/>
-            <a:r>
-              <a:rPr sz="1000" b="1">
+          <a:bodyPr rtlCol="0" anchor="ctr" wrap="none" lIns="73152" rIns="73152" tIns="9144" bIns="9144"/>
+          <a:lstStyle/>
+          <a:p>
+            <a:pPr algn="ctr"/>
+            <a:r>
+              <a:rPr sz="900" b="1">
                 <a:solidFill>
                   <a:srgbClr val="664D00"/>
                 </a:solidFill>
                 <a:latin typeface="맑은 고딕"/>
               </a:rPr>
-              <a:t>📎 사진 첨부: Constrained ESW Cl-scan + 분해반응 ΔG 막대</a:t>
+              <a:t>📎 사진 첨부: ESW Cl-scan + 분해반응 ΔG 막대</a:t>
             </a:r>
           </a:p>
         </p:txBody>
@@ -18068,10 +18068,10 @@
                 <a:tableStyleId>{5C22544A-7EE6-4342-B048-85BDC9FD1C3A}</a:tableStyleId>
               </a:tblPr>
               <a:tblGrid>
-                <a:gridCol w="2903220"/>
-                <a:gridCol w="2903220"/>
-                <a:gridCol w="2903220"/>
-                <a:gridCol w="2903220"/>
+                <a:gridCol w="548640"/>
+                <a:gridCol w="4023360"/>
+                <a:gridCol w="3657600"/>
+                <a:gridCol w="3383280"/>
               </a:tblGrid>
               <a:tr h="859536">
                 <a:tc>
@@ -18650,7 +18650,7 @@
                 </a:solidFill>
                 <a:latin typeface="맑은 고딕"/>
               </a:rPr>
-              <a:t>24 / 21</a:t>
+              <a:t>24 / 26</a:t>
             </a:r>
           </a:p>
         </p:txBody>
@@ -18771,9 +18771,9 @@
                 <a:tableStyleId>{5C22544A-7EE6-4342-B048-85BDC9FD1C3A}</a:tableStyleId>
               </a:tblPr>
               <a:tblGrid>
-                <a:gridCol w="3779520"/>
-                <a:gridCol w="3779520"/>
-                <a:gridCol w="3779520"/>
+                <a:gridCol w="548640"/>
+                <a:gridCol w="5120640"/>
+                <a:gridCol w="5669280"/>
               </a:tblGrid>
               <a:tr h="429768">
                 <a:tc>
@@ -19571,7 +19571,7 @@
                 </a:solidFill>
                 <a:latin typeface="맑은 고딕"/>
               </a:rPr>
-              <a:t>25 / 21</a:t>
+              <a:t>25 / 26</a:t>
             </a:r>
           </a:p>
         </p:txBody>
@@ -20172,7 +20172,7 @@
                 </a:solidFill>
                 <a:latin typeface="맑은 고딕"/>
               </a:rPr>
-              <a:t>26 / 21</a:t>
+              <a:t>26 / 26</a:t>
             </a:r>
           </a:p>
         </p:txBody>
@@ -20185,8 +20185,8 @@
         </p:nvSpPr>
         <p:spPr>
           <a:xfrm>
-            <a:off x="7528255" y="347472"/>
-            <a:ext cx="4206240" cy="384048"/>
+            <a:off x="6933895" y="27432"/>
+            <a:ext cx="5120640" cy="274320"/>
           </a:xfrm>
           <a:prstGeom prst="roundRect">
             <a:avLst/>
@@ -20216,18 +20216,18 @@
           </a:fontRef>
         </p:style>
         <p:txBody>
-          <a:bodyPr rtlCol="0" anchor="ctr" wrap="square" lIns="73152" rIns="73152" tIns="18288" bIns="18288"/>
-          <a:lstStyle/>
-          <a:p>
-            <a:pPr algn="l"/>
-            <a:r>
-              <a:rPr sz="1000" b="1">
+          <a:bodyPr rtlCol="0" anchor="ctr" wrap="none" lIns="73152" rIns="73152" tIns="9144" bIns="9144"/>
+          <a:lstStyle/>
+          <a:p>
+            <a:pPr algn="ctr"/>
+            <a:r>
+              <a:rPr sz="900" b="1">
                 <a:solidFill>
                   <a:srgbClr val="664D00"/>
                 </a:solidFill>
                 <a:latin typeface="맑은 고딕"/>
               </a:rPr>
-              <a:t>📎 사진 첨부: Trade-off 4축 + Paper #2 도핑 roadmap</a:t>
+              <a:t>📎 사진 첨부: Trade-off 4축 + 도핑 roadmap</a:t>
             </a:r>
           </a:p>
         </p:txBody>
@@ -20934,8 +20934,8 @@
         </p:nvSpPr>
         <p:spPr>
           <a:xfrm>
-            <a:off x="457200" y="6355080"/>
-            <a:ext cx="11247120" cy="365760"/>
+            <a:off x="457200" y="6144768"/>
+            <a:ext cx="11247120" cy="274320"/>
           </a:xfrm>
           <a:prstGeom prst="rect">
             <a:avLst/>
@@ -21026,7 +21026,7 @@
                 </a:solidFill>
                 <a:latin typeface="맑은 고딕"/>
               </a:rPr>
-              <a:t>3 / 21</a:t>
+              <a:t>3 / 26</a:t>
             </a:r>
           </a:p>
         </p:txBody>
@@ -21039,8 +21039,8 @@
         </p:nvSpPr>
         <p:spPr>
           <a:xfrm>
-            <a:off x="7528255" y="347472"/>
-            <a:ext cx="4206240" cy="384048"/>
+            <a:off x="6933895" y="27432"/>
+            <a:ext cx="5120640" cy="274320"/>
           </a:xfrm>
           <a:prstGeom prst="roundRect">
             <a:avLst/>
@@ -21070,12 +21070,12 @@
           </a:fontRef>
         </p:style>
         <p:txBody>
-          <a:bodyPr rtlCol="0" anchor="ctr" wrap="square" lIns="73152" rIns="73152" tIns="18288" bIns="18288"/>
-          <a:lstStyle/>
-          <a:p>
-            <a:pPr algn="l"/>
-            <a:r>
-              <a:rPr sz="1000" b="1">
+          <a:bodyPr rtlCol="0" anchor="ctr" wrap="none" lIns="73152" rIns="73152" tIns="9144" bIns="9144"/>
+          <a:lstStyle/>
+          <a:p>
+            <a:pPr algn="ctr"/>
+            <a:r>
+              <a:rPr sz="900" b="1">
                 <a:solidFill>
                   <a:srgbClr val="664D00"/>
                 </a:solidFill>
@@ -22246,7 +22246,7 @@
                 </a:solidFill>
                 <a:latin typeface="맑은 고딕"/>
               </a:rPr>
-              <a:t>4 / 21</a:t>
+              <a:t>4 / 26</a:t>
             </a:r>
           </a:p>
         </p:txBody>
@@ -22259,8 +22259,8 @@
         </p:nvSpPr>
         <p:spPr>
           <a:xfrm>
-            <a:off x="7528255" y="347472"/>
-            <a:ext cx="4206240" cy="384048"/>
+            <a:off x="6933895" y="27432"/>
+            <a:ext cx="5120640" cy="274320"/>
           </a:xfrm>
           <a:prstGeom prst="roundRect">
             <a:avLst/>
@@ -22290,12 +22290,12 @@
           </a:fontRef>
         </p:style>
         <p:txBody>
-          <a:bodyPr rtlCol="0" anchor="ctr" wrap="square" lIns="73152" rIns="73152" tIns="18288" bIns="18288"/>
-          <a:lstStyle/>
-          <a:p>
-            <a:pPr algn="l"/>
-            <a:r>
-              <a:rPr sz="1000" b="1">
+          <a:bodyPr rtlCol="0" anchor="ctr" wrap="none" lIns="73152" rIns="73152" tIns="9144" bIns="9144"/>
+          <a:lstStyle/>
+          <a:p>
+            <a:pPr algn="ctr"/>
+            <a:r>
+              <a:rPr sz="900" b="1">
                 <a:solidFill>
                   <a:srgbClr val="664D00"/>
                 </a:solidFill>
@@ -23250,7 +23250,7 @@
                 </a:solidFill>
                 <a:latin typeface="맑은 고딕"/>
               </a:rPr>
-              <a:t>5 / 21</a:t>
+              <a:t>5 / 26</a:t>
             </a:r>
           </a:p>
         </p:txBody>
@@ -23263,8 +23263,8 @@
         </p:nvSpPr>
         <p:spPr>
           <a:xfrm>
-            <a:off x="7528255" y="347472"/>
-            <a:ext cx="4206240" cy="384048"/>
+            <a:off x="6933895" y="27432"/>
+            <a:ext cx="5120640" cy="274320"/>
           </a:xfrm>
           <a:prstGeom prst="roundRect">
             <a:avLst/>
@@ -23294,18 +23294,18 @@
           </a:fontRef>
         </p:style>
         <p:txBody>
-          <a:bodyPr rtlCol="0" anchor="ctr" wrap="square" lIns="73152" rIns="73152" tIns="18288" bIns="18288"/>
-          <a:lstStyle/>
-          <a:p>
-            <a:pPr algn="l"/>
-            <a:r>
-              <a:rPr sz="1000" b="1">
+          <a:bodyPr rtlCol="0" anchor="ctr" wrap="none" lIns="73152" rIns="73152" tIns="9144" bIns="9144"/>
+          <a:lstStyle/>
+          <a:p>
+            <a:pPr algn="ctr"/>
+            <a:r>
+              <a:rPr sz="900" b="1">
                 <a:solidFill>
                   <a:srgbClr val="664D00"/>
                 </a:solidFill>
                 <a:latin typeface="맑은 고딕"/>
               </a:rPr>
-              <a:t>📎 사진 첨부: PDOS 비교 (comp1 vs modelc, atom-projected)</a:t>
+              <a:t>📎 사진 첨부: PDOS overlay (comp1 vs modelc)</a:t>
             </a:r>
           </a:p>
         </p:txBody>
@@ -24262,7 +24262,7 @@
                 </a:solidFill>
                 <a:latin typeface="맑은 고딕"/>
               </a:rPr>
-              <a:t>6 / 21</a:t>
+              <a:t>6 / 26</a:t>
             </a:r>
           </a:p>
         </p:txBody>
@@ -24275,8 +24275,8 @@
         </p:nvSpPr>
         <p:spPr>
           <a:xfrm>
-            <a:off x="7528255" y="347472"/>
-            <a:ext cx="4206240" cy="384048"/>
+            <a:off x="6933895" y="27432"/>
+            <a:ext cx="5120640" cy="274320"/>
           </a:xfrm>
           <a:prstGeom prst="roundRect">
             <a:avLst/>
@@ -24306,18 +24306,18 @@
           </a:fontRef>
         </p:style>
         <p:txBody>
-          <a:bodyPr rtlCol="0" anchor="ctr" wrap="square" lIns="73152" rIns="73152" tIns="18288" bIns="18288"/>
-          <a:lstStyle/>
-          <a:p>
-            <a:pPr algn="l"/>
-            <a:r>
-              <a:rPr sz="1000" b="1">
+          <a:bodyPr rtlCol="0" anchor="ctr" wrap="none" lIns="73152" rIns="73152" tIns="9144" bIns="9144"/>
+          <a:lstStyle/>
+          <a:p>
+            <a:pPr algn="ctr"/>
+            <a:r>
+              <a:rPr sz="900" b="1">
                 <a:solidFill>
                   <a:srgbClr val="664D00"/>
                 </a:solidFill>
                 <a:latin typeface="맑은 고딕"/>
               </a:rPr>
-              <a:t>📎 사진 첨부: σ(T) Arrhenius plot (paired 600/800/1000 K)</a:t>
+              <a:t>📎 사진 첨부: σ(T) Arrhenius plot (3점 paired)</a:t>
             </a:r>
           </a:p>
         </p:txBody>
@@ -24950,7 +24950,7 @@
                 </a:solidFill>
                 <a:latin typeface="맑은 고딕"/>
               </a:rPr>
-              <a:t>7 / 21</a:t>
+              <a:t>7 / 26</a:t>
             </a:r>
           </a:p>
         </p:txBody>
@@ -24963,8 +24963,8 @@
         </p:nvSpPr>
         <p:spPr>
           <a:xfrm>
-            <a:off x="7528255" y="347472"/>
-            <a:ext cx="4206240" cy="384048"/>
+            <a:off x="6933895" y="27432"/>
+            <a:ext cx="5120640" cy="274320"/>
           </a:xfrm>
           <a:prstGeom prst="roundRect">
             <a:avLst/>
@@ -24994,18 +24994,18 @@
           </a:fontRef>
         </p:style>
         <p:txBody>
-          <a:bodyPr rtlCol="0" anchor="ctr" wrap="square" lIns="73152" rIns="73152" tIns="18288" bIns="18288"/>
-          <a:lstStyle/>
-          <a:p>
-            <a:pPr algn="l"/>
-            <a:r>
-              <a:rPr sz="1000" b="1">
+          <a:bodyPr rtlCol="0" anchor="ctr" wrap="none" lIns="73152" rIns="73152" tIns="9144" bIns="9144"/>
+          <a:lstStyle/>
+          <a:p>
+            <a:pPr algn="ctr"/>
+            <a:r>
+              <a:rPr sz="900" b="1">
                 <a:solidFill>
                   <a:srgbClr val="664D00"/>
                 </a:solidFill>
                 <a:latin typeface="맑은 고딕"/>
               </a:rPr>
-              <a:t>📎 사진 첨부: D₀ vs Eₐ 산점도 또는 prefactor 비교 막대</a:t>
+              <a:t>📎 사진 첨부: D₀ vs Eₐ 산점도 / prefactor 막대</a:t>
             </a:r>
           </a:p>
         </p:txBody>
@@ -25589,7 +25589,7 @@
                 </a:solidFill>
                 <a:latin typeface="맑은 고딕"/>
               </a:rPr>
-              <a:t>8 / 21</a:t>
+              <a:t>8 / 26</a:t>
             </a:r>
           </a:p>
         </p:txBody>
@@ -25602,8 +25602,8 @@
         </p:nvSpPr>
         <p:spPr>
           <a:xfrm>
-            <a:off x="7528255" y="347472"/>
-            <a:ext cx="4206240" cy="384048"/>
+            <a:off x="6933895" y="27432"/>
+            <a:ext cx="5120640" cy="274320"/>
           </a:xfrm>
           <a:prstGeom prst="roundRect">
             <a:avLst/>
@@ -25633,18 +25633,18 @@
           </a:fontRef>
         </p:style>
         <p:txBody>
-          <a:bodyPr rtlCol="0" anchor="ctr" wrap="square" lIns="73152" rIns="73152" tIns="18288" bIns="18288"/>
-          <a:lstStyle/>
-          <a:p>
-            <a:pPr algn="l"/>
-            <a:r>
-              <a:rPr sz="1000" b="1">
+          <a:bodyPr rtlCol="0" anchor="ctr" wrap="none" lIns="73152" rIns="73152" tIns="9144" bIns="9144"/>
+          <a:lstStyle/>
+          <a:p>
+            <a:pPr algn="ctr"/>
+            <a:r>
+              <a:rPr sz="900" b="1">
                 <a:solidFill>
                   <a:srgbClr val="664D00"/>
                 </a:solidFill>
                 <a:latin typeface="맑은 고딕"/>
               </a:rPr>
-              <a:t>📎 사진 첨부: Disorder ensemble Eₐ 분포 (matched-d 그룹)</a:t>
+              <a:t>📎 사진 첨부: Disorder ensemble Eₐ 분포</a:t>
             </a:r>
           </a:p>
         </p:txBody>
@@ -26807,7 +26807,7 @@
                 </a:solidFill>
                 <a:latin typeface="맑은 고딕"/>
               </a:rPr>
-              <a:t>9 / 21</a:t>
+              <a:t>9 / 26</a:t>
             </a:r>
           </a:p>
         </p:txBody>
@@ -26820,8 +26820,8 @@
         </p:nvSpPr>
         <p:spPr>
           <a:xfrm>
-            <a:off x="7528255" y="347472"/>
-            <a:ext cx="4206240" cy="384048"/>
+            <a:off x="6933895" y="27432"/>
+            <a:ext cx="5120640" cy="274320"/>
           </a:xfrm>
           <a:prstGeom prst="roundRect">
             <a:avLst/>
@@ -26851,18 +26851,18 @@
           </a:fontRef>
         </p:style>
         <p:txBody>
-          <a:bodyPr rtlCol="0" anchor="ctr" wrap="square" lIns="73152" rIns="73152" tIns="18288" bIns="18288"/>
-          <a:lstStyle/>
-          <a:p>
-            <a:pPr algn="l"/>
-            <a:r>
-              <a:rPr sz="1000" b="1">
+          <a:bodyPr rtlCol="0" anchor="ctr" wrap="none" lIns="73152" rIns="73152" tIns="9144" bIns="9144"/>
+          <a:lstStyle/>
+          <a:p>
+            <a:pPr algn="ctr"/>
+            <a:r>
+              <a:rPr sz="900" b="1">
                 <a:solidFill>
                   <a:srgbClr val="664D00"/>
                 </a:solidFill>
                 <a:latin typeface="맑은 고딕"/>
               </a:rPr>
-              <a:t>📎 사진 첨부: σ(T) 저온 외삽 plot (300 K까지)</a:t>
+              <a:t>📎 사진 첨부: σ(T) 저온 외삽 plot (300 K)</a:t>
             </a:r>
           </a:p>
         </p:txBody>

</xml_diff>